<commit_message>
.github/deck slide 2: add Where-it-lives repo table
Three repo URLs added to slide 2 (positioning) so the audience knows
where the layered architecture lives:

  Upstream SBD (C++ core, RIKEN CCS)               github.com/r-ccs-cms/sbd
  Python wrapper (fork with python/ bindings)      github.com/hfwen0502/sbd
  Patched qiskit-addon-sqd (MPI-aware solver hook) github.com/hfwen0502/qiskit-addon-sqd
                                                   (branch: patch-ferminon-sbd)

Compacted the original "what stays / what changes" two-bullet footer
into a single one-liner so the slide doesn't get over-stuffed; trimmed
one row off the comparison table (RDMs / save-load wf, both ✓ on
both solvers — not a discriminator).

Updates: SBD_PYTHON_DECK.md adds a "Where it lives" sub-section under
the comparison table; build_deck.py rebuilds slide 2 with two tables
(comparison + repos) and the compact footer; SBD_PYTHON_DECK.pptx
regenerated.

Co-Authored-By: Claude Opus 4.7 <noreply@anthropic.com>
</commit_message>
<xml_diff>
--- a/.github/SBD_PYTHON_DECK.pptx
+++ b/.github/SBD_PYTHON_DECK.pptx
@@ -4488,7 +4488,7 @@
         </p:nvGraphicFramePr>
         <p:xfrm>
           <a:off x="457200" y="1554480"/>
-          <a:ext cx="11247120" cy="3200400"/>
+          <a:ext cx="11247120" cy="2377440"/>
         </p:xfrm>
         <a:graphic>
           <a:graphicData uri="http://schemas.openxmlformats.org/drawingml/2006/table">
@@ -4501,7 +4501,7 @@
                 <a:gridCol w="3749040"/>
                 <a:gridCol w="3749040"/>
               </a:tblGrid>
-              <a:tr h="457200">
+              <a:tr h="396240">
                 <a:tc>
                   <a:txBody>
                     <a:bodyPr/>
@@ -4559,7 +4559,7 @@
                   </a:tcPr>
                 </a:tc>
               </a:tr>
-              <a:tr h="457200">
+              <a:tr h="396240">
                 <a:tc>
                   <a:txBody>
                     <a:bodyPr/>
@@ -4627,7 +4627,7 @@
                   </a:tcPr>
                 </a:tc>
               </a:tr>
-              <a:tr h="457200">
+              <a:tr h="396240">
                 <a:tc>
                   <a:txBody>
                     <a:bodyPr/>
@@ -4695,7 +4695,7 @@
                   </a:tcPr>
                 </a:tc>
               </a:tr>
-              <a:tr h="457200">
+              <a:tr h="396240">
                 <a:tc>
                   <a:txBody>
                     <a:bodyPr/>
@@ -4763,7 +4763,7 @@
                   </a:tcPr>
                 </a:tc>
               </a:tr>
-              <a:tr h="457200">
+              <a:tr h="396240">
                 <a:tc>
                   <a:txBody>
                     <a:bodyPr/>
@@ -4831,7 +4831,7 @@
                   </a:tcPr>
                 </a:tc>
               </a:tr>
-              <a:tr h="457200">
+              <a:tr h="396240">
                 <a:tc>
                   <a:txBody>
                     <a:bodyPr/>
@@ -4844,7 +4844,7 @@
                           </a:solidFill>
                           <a:latin typeface="Calibri"/>
                         </a:rPr>
-                        <a:t>1-/2-RDM, save/load wf</a:t>
+                        <a:t>Integration with sqd-addon</a:t>
                       </a:r>
                     </a:p>
                   </a:txBody>
@@ -4866,7 +4866,7 @@
                           </a:solidFill>
                           <a:latin typeface="Calibri"/>
                         </a:rPr>
-                        <a:t>✓</a:t>
+                        <a:t>stock package</a:t>
                       </a:r>
                     </a:p>
                   </a:txBody>
@@ -4888,7 +4888,7 @@
                           </a:solidFill>
                           <a:latin typeface="Calibri"/>
                         </a:rPr>
-                        <a:t>✓</a:t>
+                        <a:t>MPI-aware fork (@patch-ferminon-sbd)</a:t>
                       </a:r>
                     </a:p>
                   </a:txBody>
@@ -4899,7 +4899,113 @@
                   </a:tcPr>
                 </a:tc>
               </a:tr>
-              <a:tr h="457200">
+            </a:tbl>
+          </a:graphicData>
+        </a:graphic>
+      </p:graphicFrame>
+      <p:sp>
+        <p:nvSpPr>
+          <p:cNvPr id="4" name="TextBox 3"/>
+          <p:cNvSpPr txBox="1"/>
+          <p:nvPr/>
+        </p:nvSpPr>
+        <p:spPr>
+          <a:xfrm>
+            <a:off x="457200" y="4114800"/>
+            <a:ext cx="11247120" cy="365760"/>
+          </a:xfrm>
+          <a:prstGeom prst="rect">
+            <a:avLst/>
+          </a:prstGeom>
+          <a:noFill/>
+        </p:spPr>
+        <p:txBody>
+          <a:bodyPr wrap="square">
+            <a:spAutoFit/>
+          </a:bodyPr>
+          <a:lstStyle/>
+          <a:p>
+            <a:r>
+              <a:rPr sz="1600" b="1">
+                <a:solidFill>
+                  <a:srgbClr val="0F62FE"/>
+                </a:solidFill>
+                <a:latin typeface="Calibri"/>
+              </a:rPr>
+              <a:t>Where it lives</a:t>
+            </a:r>
+          </a:p>
+        </p:txBody>
+      </p:sp>
+      <p:graphicFrame>
+        <p:nvGraphicFramePr>
+          <p:cNvPr id="5" name="Table 4"/>
+          <p:cNvGraphicFramePr>
+            <a:graphicFrameLocks noGrp="1"/>
+          </p:cNvGraphicFramePr>
+          <p:nvPr/>
+        </p:nvGraphicFramePr>
+        <p:xfrm>
+          <a:off x="457200" y="4526280"/>
+          <a:ext cx="11247120" cy="1371600"/>
+        </p:xfrm>
+        <a:graphic>
+          <a:graphicData uri="http://schemas.openxmlformats.org/drawingml/2006/table">
+            <a:tbl>
+              <a:tblPr firstRow="1" bandRow="1">
+                <a:tableStyleId>{5C22544A-7EE6-4342-B048-85BDC9FD1C3A}</a:tableStyleId>
+              </a:tblPr>
+              <a:tblGrid>
+                <a:gridCol w="5623560"/>
+                <a:gridCol w="5623560"/>
+              </a:tblGrid>
+              <a:tr h="342900">
+                <a:tc>
+                  <a:txBody>
+                    <a:bodyPr/>
+                    <a:lstStyle/>
+                    <a:p>
+                      <a:r>
+                        <a:rPr sz="1400" b="1">
+                          <a:solidFill>
+                            <a:srgbClr val="FFFFFF"/>
+                          </a:solidFill>
+                          <a:latin typeface="Calibri"/>
+                        </a:rPr>
+                        <a:t>Layer</a:t>
+                      </a:r>
+                    </a:p>
+                  </a:txBody>
+                  <a:tcPr>
+                    <a:solidFill>
+                      <a:srgbClr val="0F62FE"/>
+                    </a:solidFill>
+                  </a:tcPr>
+                </a:tc>
+                <a:tc>
+                  <a:txBody>
+                    <a:bodyPr/>
+                    <a:lstStyle/>
+                    <a:p>
+                      <a:r>
+                        <a:rPr sz="1400" b="1">
+                          <a:solidFill>
+                            <a:srgbClr val="FFFFFF"/>
+                          </a:solidFill>
+                          <a:latin typeface="Calibri"/>
+                        </a:rPr>
+                        <a:t>Repo</a:t>
+                      </a:r>
+                    </a:p>
+                  </a:txBody>
+                  <a:tcPr>
+                    <a:solidFill>
+                      <a:srgbClr val="0F62FE"/>
+                    </a:solidFill>
+                  </a:tcPr>
+                </a:tc>
+              </a:tr>
+              <a:tr h="342900">
                 <a:tc>
                   <a:txBody>
                     <a:bodyPr/>
@@ -4912,7 +5018,53 @@
                           </a:solidFill>
                           <a:latin typeface="Calibri"/>
                         </a:rPr>
-                        <a:t>Integration with sqd-addon</a:t>
+                        <a:t>Upstream SBD (C++ core, RIKEN CCS)</a:t>
+                      </a:r>
+                    </a:p>
+                  </a:txBody>
+                  <a:tcPr>
+                    <a:solidFill>
+                      <a:srgbClr val="F4F4F4"/>
+                    </a:solidFill>
+                  </a:tcPr>
+                </a:tc>
+                <a:tc>
+                  <a:txBody>
+                    <a:bodyPr/>
+                    <a:lstStyle/>
+                    <a:p>
+                      <a:r>
+                        <a:rPr sz="1400">
+                          <a:solidFill>
+                            <a:srgbClr val="161616"/>
+                          </a:solidFill>
+                          <a:latin typeface="Calibri"/>
+                        </a:rPr>
+                        <a:t>github.com/r-ccs-cms/sbd</a:t>
+                      </a:r>
+                    </a:p>
+                  </a:txBody>
+                  <a:tcPr>
+                    <a:solidFill>
+                      <a:srgbClr val="F4F4F4"/>
+                    </a:solidFill>
+                  </a:tcPr>
+                </a:tc>
+              </a:tr>
+              <a:tr h="342900">
+                <a:tc>
+                  <a:txBody>
+                    <a:bodyPr/>
+                    <a:lstStyle/>
+                    <a:p>
+                      <a:r>
+                        <a:rPr sz="1400">
+                          <a:solidFill>
+                            <a:srgbClr val="161616"/>
+                          </a:solidFill>
+                          <a:latin typeface="Calibri"/>
+                        </a:rPr>
+                        <a:t>Python wrapper (fork with python/ bindings)</a:t>
                       </a:r>
                     </a:p>
                   </a:txBody>
@@ -4934,13 +5086,37 @@
                           </a:solidFill>
                           <a:latin typeface="Calibri"/>
                         </a:rPr>
-                        <a:t>stock package</a:t>
+                        <a:t>github.com/hfwen0502/sbd</a:t>
                       </a:r>
                     </a:p>
                   </a:txBody>
                   <a:tcPr>
                     <a:solidFill>
                       <a:srgbClr val="FFFFFF"/>
+                    </a:solidFill>
+                  </a:tcPr>
+                </a:tc>
+              </a:tr>
+              <a:tr h="342900">
+                <a:tc>
+                  <a:txBody>
+                    <a:bodyPr/>
+                    <a:lstStyle/>
+                    <a:p>
+                      <a:r>
+                        <a:rPr sz="1400">
+                          <a:solidFill>
+                            <a:srgbClr val="161616"/>
+                          </a:solidFill>
+                          <a:latin typeface="Calibri"/>
+                        </a:rPr>
+                        <a:t>Patched qiskit-addon-sqd (MPI-aware solver hook)</a:t>
+                      </a:r>
+                    </a:p>
+                  </a:txBody>
+                  <a:tcPr>
+                    <a:solidFill>
+                      <a:srgbClr val="F4F4F4"/>
                     </a:solidFill>
                   </a:tcPr>
                 </a:tc>
@@ -4956,13 +5132,13 @@
                           </a:solidFill>
                           <a:latin typeface="Calibri"/>
                         </a:rPr>
-                        <a:t>MPI-aware fork (@patch-ferminon-sbd)</a:t>
+                        <a:t>github.com/hfwen0502/qiskit-addon-sqd  (branch: patch-ferminon-sbd)</a:t>
                       </a:r>
                     </a:p>
                   </a:txBody>
                   <a:tcPr>
                     <a:solidFill>
-                      <a:srgbClr val="FFFFFF"/>
+                      <a:srgbClr val="F4F4F4"/>
                     </a:solidFill>
                   </a:tcPr>
                 </a:tc>
@@ -4973,14 +5149,14 @@
       </p:graphicFrame>
       <p:sp>
         <p:nvSpPr>
-          <p:cNvPr id="4" name="TextBox 3"/>
+          <p:cNvPr id="6" name="TextBox 5"/>
           <p:cNvSpPr txBox="1"/>
           <p:nvPr/>
         </p:nvSpPr>
         <p:spPr>
           <a:xfrm>
-            <a:off x="457200" y="5029200"/>
-            <a:ext cx="11247120" cy="1371600"/>
+            <a:off x="457200" y="5989320"/>
+            <a:ext cx="11247120" cy="365760"/>
           </a:xfrm>
           <a:prstGeom prst="rect">
             <a:avLst/>
@@ -4994,31 +5170,20 @@
           <a:lstStyle/>
           <a:p>
             <a:r>
-              <a:rPr sz="1500">
-                <a:solidFill>
-                  <a:srgbClr val="161616"/>
+              <a:rPr sz="1300">
+                <a:solidFill>
+                  <a:srgbClr val="69767A"/>
                 </a:solidFill>
                 <a:latin typeface="Calibri"/>
               </a:rPr>
-              <a:t>What stays the same: FCIDUMP input, RDM outputs, role inside the SQD loop, carryover concept.</a:t>
-            </a:r>
-          </a:p>
-          <a:p>
-            <a:r>
-              <a:rPr sz="1500">
-                <a:solidFill>
-                  <a:srgbClr val="161616"/>
-                </a:solidFill>
-                <a:latin typeface="Calibri"/>
-              </a:rPr>
-              <a:t>What changes: in-process call instead of subprocess, GPU-aware, designed for much larger subspaces.</a:t>
-            </a:r>
-          </a:p>
-        </p:txBody>
-      </p:sp>
-      <p:sp>
-        <p:nvSpPr>
-          <p:cNvPr id="5" name="TextBox 4"/>
+              <a:t>Same FCIDUMP input, same RDM outputs, same role in the SQD loop. Process model and hardware envelope are what change.</a:t>
+            </a:r>
+          </a:p>
+        </p:txBody>
+      </p:sp>
+      <p:sp>
+        <p:nvSpPr>
+          <p:cNvPr id="7" name="TextBox 6"/>
           <p:cNvSpPr txBox="1"/>
           <p:nvPr/>
         </p:nvSpPr>

</xml_diff>